<commit_message>
Refine documentation and presentation wording
</commit_message>
<xml_diff>
--- a/presentation.pptx
+++ b/presentation.pptx
@@ -3728,7 +3728,7 @@
                   <a:srgbClr val="1A233A"/>
                 </a:solidFill>
               </a:rPr>
-              <a:t>Scalability — honest assessment</a:t>
+              <a:t>Scalability — assessment</a:t>
             </a:r>
           </a:p>
         </p:txBody>
@@ -7423,7 +7423,7 @@
                   <a:srgbClr val="FFFFFF"/>
                 </a:solidFill>
               </a:rPr>
-              <a:t>Pillar 1: Impact Forecasting — Honest Model Results</a:t>
+              <a:t>Pillar 1: Impact Forecasting — Model Results</a:t>
             </a:r>
           </a:p>
           <a:p>
@@ -7618,7 +7618,7 @@
                   <a:srgbClr val="1A233A"/>
                 </a:solidFill>
               </a:rPr>
-              <a:t>Duration benchmark  —  honest planning uncertainty</a:t>
+              <a:t>Duration benchmark  —  planning uncertainty</a:t>
             </a:r>
           </a:p>
           <a:p>

</xml_diff>